<commit_message>
measure classify, compare, distance, level
</commit_message>
<xml_diff>
--- a/LucusEdge 자료_0522.pptx
+++ b/LucusEdge 자료_0522.pptx
@@ -7,7 +7,14 @@
   <p:sldIdLst>
     <p:sldId id="257" r:id="rId2"/>
     <p:sldId id="258" r:id="rId3"/>
-    <p:sldId id="259" r:id="rId4"/>
+    <p:sldId id="260" r:id="rId4"/>
+    <p:sldId id="259" r:id="rId5"/>
+    <p:sldId id="261" r:id="rId6"/>
+    <p:sldId id="262" r:id="rId7"/>
+    <p:sldId id="265" r:id="rId8"/>
+    <p:sldId id="264" r:id="rId9"/>
+    <p:sldId id="267" r:id="rId10"/>
+    <p:sldId id="266" r:id="rId11"/>
   </p:sldIdLst>
   <p:sldSz cx="12192000" cy="6858000"/>
   <p:notesSz cx="6858000" cy="9144000"/>
@@ -261,7 +268,7 @@
           <a:p>
             <a:fld id="{8E3C091C-16D3-452B-9144-68BEFF1CF479}" type="datetimeFigureOut">
               <a:rPr lang="ko-KR" altLang="en-US" smtClean="0"/>
-              <a:t>2026-05-22</a:t>
+              <a:t>2026-05-26</a:t>
             </a:fld>
             <a:endParaRPr lang="ko-KR" altLang="en-US"/>
           </a:p>
@@ -459,7 +466,7 @@
           <a:p>
             <a:fld id="{8E3C091C-16D3-452B-9144-68BEFF1CF479}" type="datetimeFigureOut">
               <a:rPr lang="ko-KR" altLang="en-US" smtClean="0"/>
-              <a:t>2026-05-22</a:t>
+              <a:t>2026-05-26</a:t>
             </a:fld>
             <a:endParaRPr lang="ko-KR" altLang="en-US"/>
           </a:p>
@@ -667,7 +674,7 @@
           <a:p>
             <a:fld id="{8E3C091C-16D3-452B-9144-68BEFF1CF479}" type="datetimeFigureOut">
               <a:rPr lang="ko-KR" altLang="en-US" smtClean="0"/>
-              <a:t>2026-05-22</a:t>
+              <a:t>2026-05-26</a:t>
             </a:fld>
             <a:endParaRPr lang="ko-KR" altLang="en-US"/>
           </a:p>
@@ -865,7 +872,7 @@
           <a:p>
             <a:fld id="{8E3C091C-16D3-452B-9144-68BEFF1CF479}" type="datetimeFigureOut">
               <a:rPr lang="ko-KR" altLang="en-US" smtClean="0"/>
-              <a:t>2026-05-22</a:t>
+              <a:t>2026-05-26</a:t>
             </a:fld>
             <a:endParaRPr lang="ko-KR" altLang="en-US"/>
           </a:p>
@@ -1140,7 +1147,7 @@
           <a:p>
             <a:fld id="{8E3C091C-16D3-452B-9144-68BEFF1CF479}" type="datetimeFigureOut">
               <a:rPr lang="ko-KR" altLang="en-US" smtClean="0"/>
-              <a:t>2026-05-22</a:t>
+              <a:t>2026-05-26</a:t>
             </a:fld>
             <a:endParaRPr lang="ko-KR" altLang="en-US"/>
           </a:p>
@@ -1405,7 +1412,7 @@
           <a:p>
             <a:fld id="{8E3C091C-16D3-452B-9144-68BEFF1CF479}" type="datetimeFigureOut">
               <a:rPr lang="ko-KR" altLang="en-US" smtClean="0"/>
-              <a:t>2026-05-22</a:t>
+              <a:t>2026-05-26</a:t>
             </a:fld>
             <a:endParaRPr lang="ko-KR" altLang="en-US"/>
           </a:p>
@@ -1817,7 +1824,7 @@
           <a:p>
             <a:fld id="{8E3C091C-16D3-452B-9144-68BEFF1CF479}" type="datetimeFigureOut">
               <a:rPr lang="ko-KR" altLang="en-US" smtClean="0"/>
-              <a:t>2026-05-22</a:t>
+              <a:t>2026-05-26</a:t>
             </a:fld>
             <a:endParaRPr lang="ko-KR" altLang="en-US"/>
           </a:p>
@@ -1958,7 +1965,7 @@
           <a:p>
             <a:fld id="{8E3C091C-16D3-452B-9144-68BEFF1CF479}" type="datetimeFigureOut">
               <a:rPr lang="ko-KR" altLang="en-US" smtClean="0"/>
-              <a:t>2026-05-22</a:t>
+              <a:t>2026-05-26</a:t>
             </a:fld>
             <a:endParaRPr lang="ko-KR" altLang="en-US"/>
           </a:p>
@@ -2071,7 +2078,7 @@
           <a:p>
             <a:fld id="{8E3C091C-16D3-452B-9144-68BEFF1CF479}" type="datetimeFigureOut">
               <a:rPr lang="ko-KR" altLang="en-US" smtClean="0"/>
-              <a:t>2026-05-22</a:t>
+              <a:t>2026-05-26</a:t>
             </a:fld>
             <a:endParaRPr lang="ko-KR" altLang="en-US"/>
           </a:p>
@@ -2382,7 +2389,7 @@
           <a:p>
             <a:fld id="{8E3C091C-16D3-452B-9144-68BEFF1CF479}" type="datetimeFigureOut">
               <a:rPr lang="ko-KR" altLang="en-US" smtClean="0"/>
-              <a:t>2026-05-22</a:t>
+              <a:t>2026-05-26</a:t>
             </a:fld>
             <a:endParaRPr lang="ko-KR" altLang="en-US"/>
           </a:p>
@@ -2670,7 +2677,7 @@
           <a:p>
             <a:fld id="{8E3C091C-16D3-452B-9144-68BEFF1CF479}" type="datetimeFigureOut">
               <a:rPr lang="ko-KR" altLang="en-US" smtClean="0"/>
-              <a:t>2026-05-22</a:t>
+              <a:t>2026-05-26</a:t>
             </a:fld>
             <a:endParaRPr lang="ko-KR" altLang="en-US"/>
           </a:p>
@@ -2911,7 +2918,7 @@
           <a:p>
             <a:fld id="{8E3C091C-16D3-452B-9144-68BEFF1CF479}" type="datetimeFigureOut">
               <a:rPr lang="ko-KR" altLang="en-US" smtClean="0"/>
-              <a:t>2026-05-22</a:t>
+              <a:t>2026-05-26</a:t>
             </a:fld>
             <a:endParaRPr lang="ko-KR" altLang="en-US"/>
           </a:p>
@@ -3393,8 +3400,8 @@
               <a:t> </a:t>
             </a:r>
             <a:r>
-              <a:rPr lang="en-US" altLang="ko-KR" dirty="0"/>
-              <a:t>5/22~20</a:t>
+              <a:rPr lang="en-US" altLang="ko-KR"/>
+              <a:t>5/22~20, 26</a:t>
             </a:r>
             <a:endParaRPr lang="ko-KR" altLang="en-US" dirty="0"/>
           </a:p>
@@ -3404,6 +3411,91 @@
     <p:extLst>
       <p:ext uri="{BB962C8B-B14F-4D97-AF65-F5344CB8AC3E}">
         <p14:creationId xmlns:p14="http://schemas.microsoft.com/office/powerpoint/2010/main" val="2304299320"/>
+      </p:ext>
+    </p:extLst>
+  </p:cSld>
+  <p:clrMapOvr>
+    <a:masterClrMapping/>
+  </p:clrMapOvr>
+</p:sld>
+</file>
+
+<file path=ppt/slides/slide10.xml><?xml version="1.0" encoding="utf-8"?>
+<p:sld xmlns:a="http://schemas.openxmlformats.org/drawingml/2006/main" xmlns:r="http://schemas.openxmlformats.org/officeDocument/2006/relationships" xmlns:p="http://schemas.openxmlformats.org/presentationml/2006/main">
+  <p:cSld>
+    <p:spTree>
+      <p:nvGrpSpPr>
+        <p:cNvPr id="1" name=""/>
+        <p:cNvGrpSpPr/>
+        <p:nvPr/>
+      </p:nvGrpSpPr>
+      <p:grpSpPr>
+        <a:xfrm>
+          <a:off x="0" y="0"/>
+          <a:ext cx="0" cy="0"/>
+          <a:chOff x="0" y="0"/>
+          <a:chExt cx="0" cy="0"/>
+        </a:xfrm>
+      </p:grpSpPr>
+      <p:sp>
+        <p:nvSpPr>
+          <p:cNvPr id="2" name="제목 1">
+            <a:extLst>
+              <a:ext uri="{FF2B5EF4-FFF2-40B4-BE49-F238E27FC236}">
+                <a16:creationId xmlns:a16="http://schemas.microsoft.com/office/drawing/2014/main" id="{8725DA8A-EF63-05BD-7287-D07D4203173F}"/>
+              </a:ext>
+            </a:extLst>
+          </p:cNvPr>
+          <p:cNvSpPr>
+            <a:spLocks noGrp="1"/>
+          </p:cNvSpPr>
+          <p:nvPr>
+            <p:ph type="title"/>
+          </p:nvPr>
+        </p:nvSpPr>
+        <p:spPr/>
+        <p:txBody>
+          <a:bodyPr/>
+          <a:lstStyle/>
+          <a:p>
+            <a:endParaRPr lang="ko-KR" altLang="en-US"/>
+          </a:p>
+        </p:txBody>
+      </p:sp>
+      <p:pic>
+        <p:nvPicPr>
+          <p:cNvPr id="4" name="그림 3">
+            <a:extLst>
+              <a:ext uri="{FF2B5EF4-FFF2-40B4-BE49-F238E27FC236}">
+                <a16:creationId xmlns:a16="http://schemas.microsoft.com/office/drawing/2014/main" id="{0CDE5785-CECD-8AA7-A42A-0FDCBC51F5DA}"/>
+              </a:ext>
+            </a:extLst>
+          </p:cNvPr>
+          <p:cNvPicPr>
+            <a:picLocks noChangeAspect="1"/>
+          </p:cNvPicPr>
+          <p:nvPr/>
+        </p:nvPicPr>
+        <p:blipFill>
+          <a:blip r:embed="rId2"/>
+          <a:stretch>
+            <a:fillRect/>
+          </a:stretch>
+        </p:blipFill>
+        <p:spPr>
+          <a:xfrm>
+            <a:off x="0" y="859086"/>
+            <a:ext cx="12192000" cy="5139827"/>
+          </a:xfrm>
+          <a:prstGeom prst="rect">
+            <a:avLst/>
+          </a:prstGeom>
+        </p:spPr>
+      </p:pic>
+    </p:spTree>
+    <p:extLst>
+      <p:ext uri="{BB962C8B-B14F-4D97-AF65-F5344CB8AC3E}">
+        <p14:creationId xmlns:p14="http://schemas.microsoft.com/office/powerpoint/2010/main" val="656720909"/>
       </p:ext>
     </p:extLst>
   </p:cSld>
@@ -3766,6 +3858,320 @@
   <p:cSld>
     <p:spTree>
       <p:nvGrpSpPr>
+        <p:cNvPr id="1" name="">
+          <a:extLst>
+            <a:ext uri="{FF2B5EF4-FFF2-40B4-BE49-F238E27FC236}">
+              <a16:creationId xmlns:a16="http://schemas.microsoft.com/office/drawing/2014/main" id="{DFE60B50-1D87-FF3E-D20E-EF3B6A878654}"/>
+            </a:ext>
+          </a:extLst>
+        </p:cNvPr>
+        <p:cNvGrpSpPr/>
+        <p:nvPr/>
+      </p:nvGrpSpPr>
+      <p:grpSpPr>
+        <a:xfrm>
+          <a:off x="0" y="0"/>
+          <a:ext cx="0" cy="0"/>
+          <a:chOff x="0" y="0"/>
+          <a:chExt cx="0" cy="0"/>
+        </a:xfrm>
+      </p:grpSpPr>
+      <p:sp>
+        <p:nvSpPr>
+          <p:cNvPr id="6" name="제목 5">
+            <a:extLst>
+              <a:ext uri="{FF2B5EF4-FFF2-40B4-BE49-F238E27FC236}">
+                <a16:creationId xmlns:a16="http://schemas.microsoft.com/office/drawing/2014/main" id="{8DF66EC0-325D-11F7-5FF5-BAA316504FA6}"/>
+              </a:ext>
+            </a:extLst>
+          </p:cNvPr>
+          <p:cNvSpPr>
+            <a:spLocks noGrp="1"/>
+          </p:cNvSpPr>
+          <p:nvPr>
+            <p:ph type="title"/>
+          </p:nvPr>
+        </p:nvSpPr>
+        <p:spPr>
+          <a:xfrm>
+            <a:off x="173182" y="171160"/>
+            <a:ext cx="2505364" cy="558511"/>
+          </a:xfrm>
+        </p:spPr>
+        <p:txBody>
+          <a:bodyPr>
+            <a:normAutofit/>
+          </a:bodyPr>
+          <a:lstStyle/>
+          <a:p>
+            <a:r>
+              <a:rPr lang="en-US" altLang="ko-KR" sz="2000" dirty="0"/>
+              <a:t>Measure Classify</a:t>
+            </a:r>
+            <a:endParaRPr lang="ko-KR" altLang="en-US" sz="2000" dirty="0"/>
+          </a:p>
+        </p:txBody>
+      </p:sp>
+      <p:sp>
+        <p:nvSpPr>
+          <p:cNvPr id="9" name="TextBox 8">
+            <a:extLst>
+              <a:ext uri="{FF2B5EF4-FFF2-40B4-BE49-F238E27FC236}">
+                <a16:creationId xmlns:a16="http://schemas.microsoft.com/office/drawing/2014/main" id="{F44D5D3A-26BF-0662-5484-BA65CD2B0719}"/>
+              </a:ext>
+            </a:extLst>
+          </p:cNvPr>
+          <p:cNvSpPr txBox="1"/>
+          <p:nvPr/>
+        </p:nvSpPr>
+        <p:spPr>
+          <a:xfrm>
+            <a:off x="237837" y="697480"/>
+            <a:ext cx="1025236" cy="276999"/>
+          </a:xfrm>
+          <a:prstGeom prst="rect">
+            <a:avLst/>
+          </a:prstGeom>
+          <a:noFill/>
+        </p:spPr>
+        <p:txBody>
+          <a:bodyPr wrap="square" rtlCol="0">
+            <a:spAutoFit/>
+          </a:bodyPr>
+          <a:lstStyle/>
+          <a:p>
+            <a:r>
+              <a:rPr lang="ko-KR" altLang="en-US" sz="1200" dirty="0"/>
+              <a:t>노드 구조</a:t>
+            </a:r>
+          </a:p>
+        </p:txBody>
+      </p:sp>
+      <p:sp>
+        <p:nvSpPr>
+          <p:cNvPr id="10" name="TextBox 9">
+            <a:extLst>
+              <a:ext uri="{FF2B5EF4-FFF2-40B4-BE49-F238E27FC236}">
+                <a16:creationId xmlns:a16="http://schemas.microsoft.com/office/drawing/2014/main" id="{10D6F74F-965C-592D-03AE-719EE603608C}"/>
+              </a:ext>
+            </a:extLst>
+          </p:cNvPr>
+          <p:cNvSpPr txBox="1"/>
+          <p:nvPr/>
+        </p:nvSpPr>
+        <p:spPr>
+          <a:xfrm>
+            <a:off x="7269324" y="602763"/>
+            <a:ext cx="1025236" cy="276999"/>
+          </a:xfrm>
+          <a:prstGeom prst="rect">
+            <a:avLst/>
+          </a:prstGeom>
+          <a:noFill/>
+        </p:spPr>
+        <p:txBody>
+          <a:bodyPr wrap="square" rtlCol="0">
+            <a:spAutoFit/>
+          </a:bodyPr>
+          <a:lstStyle/>
+          <a:p>
+            <a:r>
+              <a:rPr lang="en-US" altLang="ko-KR" sz="1200" dirty="0"/>
+              <a:t>Input</a:t>
+            </a:r>
+            <a:r>
+              <a:rPr lang="ko-KR" altLang="en-US" sz="1200" dirty="0"/>
+              <a:t> </a:t>
+            </a:r>
+            <a:r>
+              <a:rPr lang="en-US" altLang="ko-KR" sz="1200" dirty="0"/>
+              <a:t>image</a:t>
+            </a:r>
+            <a:endParaRPr lang="ko-KR" altLang="en-US" sz="1200" dirty="0"/>
+          </a:p>
+        </p:txBody>
+      </p:sp>
+      <p:sp>
+        <p:nvSpPr>
+          <p:cNvPr id="11" name="TextBox 10">
+            <a:extLst>
+              <a:ext uri="{FF2B5EF4-FFF2-40B4-BE49-F238E27FC236}">
+                <a16:creationId xmlns:a16="http://schemas.microsoft.com/office/drawing/2014/main" id="{11907A8A-7B37-D064-9C12-92AB6D1F5382}"/>
+              </a:ext>
+            </a:extLst>
+          </p:cNvPr>
+          <p:cNvSpPr txBox="1"/>
+          <p:nvPr/>
+        </p:nvSpPr>
+        <p:spPr>
+          <a:xfrm>
+            <a:off x="339437" y="4895245"/>
+            <a:ext cx="10579435" cy="646331"/>
+          </a:xfrm>
+          <a:prstGeom prst="rect">
+            <a:avLst/>
+          </a:prstGeom>
+          <a:noFill/>
+        </p:spPr>
+        <p:txBody>
+          <a:bodyPr wrap="none" rtlCol="0">
+            <a:spAutoFit/>
+          </a:bodyPr>
+          <a:lstStyle/>
+          <a:p>
+            <a:r>
+              <a:rPr lang="en-US" altLang="ko-KR" dirty="0"/>
+              <a:t>- Measure Classify</a:t>
+            </a:r>
+          </a:p>
+          <a:p>
+            <a:r>
+              <a:rPr lang="en-US" altLang="ko-KR" dirty="0"/>
+              <a:t>Input Source Image / Invert </a:t>
+            </a:r>
+            <a:r>
+              <a:rPr lang="ko-KR" altLang="en-US" dirty="0"/>
+              <a:t>🗸 </a:t>
+            </a:r>
+            <a:r>
+              <a:rPr lang="en-US" altLang="ko-KR" dirty="0"/>
+              <a:t>/ </a:t>
+            </a:r>
+            <a:r>
+              <a:rPr lang="en-US" altLang="ko-KR" dirty="0" err="1"/>
+              <a:t>Inminimum</a:t>
+            </a:r>
+            <a:r>
+              <a:rPr lang="en-US" altLang="ko-KR" dirty="0"/>
+              <a:t> 2220.0000 / </a:t>
+            </a:r>
+            <a:r>
+              <a:rPr lang="en-US" altLang="ko-KR" dirty="0" err="1"/>
+              <a:t>Inmaximum</a:t>
+            </a:r>
+            <a:r>
+              <a:rPr lang="en-US" altLang="ko-KR" dirty="0"/>
+              <a:t> 5000.0000 / Display Mode Fill</a:t>
+            </a:r>
+            <a:endParaRPr lang="ko-KR" altLang="en-US" dirty="0"/>
+          </a:p>
+        </p:txBody>
+      </p:sp>
+      <p:pic>
+        <p:nvPicPr>
+          <p:cNvPr id="2" name="그림 1">
+            <a:extLst>
+              <a:ext uri="{FF2B5EF4-FFF2-40B4-BE49-F238E27FC236}">
+                <a16:creationId xmlns:a16="http://schemas.microsoft.com/office/drawing/2014/main" id="{22F7950C-A71D-A686-2545-35738EC9985C}"/>
+              </a:ext>
+            </a:extLst>
+          </p:cNvPr>
+          <p:cNvPicPr>
+            <a:picLocks noChangeAspect="1"/>
+          </p:cNvPicPr>
+          <p:nvPr/>
+        </p:nvPicPr>
+        <p:blipFill>
+          <a:blip r:embed="rId2"/>
+          <a:srcRect l="24697" t="22383" r="28939" b="17997"/>
+          <a:stretch>
+            <a:fillRect/>
+          </a:stretch>
+        </p:blipFill>
+        <p:spPr>
+          <a:xfrm>
+            <a:off x="339437" y="974479"/>
+            <a:ext cx="5652654" cy="3075709"/>
+          </a:xfrm>
+          <a:prstGeom prst="rect">
+            <a:avLst/>
+          </a:prstGeom>
+        </p:spPr>
+      </p:pic>
+      <p:pic>
+        <p:nvPicPr>
+          <p:cNvPr id="4" name="그림 3">
+            <a:extLst>
+              <a:ext uri="{FF2B5EF4-FFF2-40B4-BE49-F238E27FC236}">
+                <a16:creationId xmlns:a16="http://schemas.microsoft.com/office/drawing/2014/main" id="{1FD51CFA-C71F-5982-DC70-9ACF5FA54E37}"/>
+              </a:ext>
+            </a:extLst>
+          </p:cNvPr>
+          <p:cNvPicPr>
+            <a:picLocks noChangeAspect="1"/>
+          </p:cNvPicPr>
+          <p:nvPr/>
+        </p:nvPicPr>
+        <p:blipFill>
+          <a:blip r:embed="rId3">
+            <a:extLst>
+              <a:ext uri="{28A0092B-C50C-407E-A947-70E740481C1C}">
+                <a14:useLocalDpi xmlns:a14="http://schemas.microsoft.com/office/drawing/2010/main" val="0"/>
+              </a:ext>
+            </a:extLst>
+          </a:blip>
+          <a:stretch>
+            <a:fillRect/>
+          </a:stretch>
+        </p:blipFill>
+        <p:spPr>
+          <a:xfrm>
+            <a:off x="7406637" y="974237"/>
+            <a:ext cx="2094457" cy="1570843"/>
+          </a:xfrm>
+          <a:prstGeom prst="rect">
+            <a:avLst/>
+          </a:prstGeom>
+        </p:spPr>
+      </p:pic>
+      <p:pic>
+        <p:nvPicPr>
+          <p:cNvPr id="8" name="그림 7">
+            <a:extLst>
+              <a:ext uri="{FF2B5EF4-FFF2-40B4-BE49-F238E27FC236}">
+                <a16:creationId xmlns:a16="http://schemas.microsoft.com/office/drawing/2014/main" id="{5AD4D2BE-82D9-C5B6-3256-5F5B471E150B}"/>
+              </a:ext>
+            </a:extLst>
+          </p:cNvPr>
+          <p:cNvPicPr>
+            <a:picLocks noChangeAspect="1"/>
+          </p:cNvPicPr>
+          <p:nvPr/>
+        </p:nvPicPr>
+        <p:blipFill>
+          <a:blip r:embed="rId4"/>
+          <a:stretch>
+            <a:fillRect/>
+          </a:stretch>
+        </p:blipFill>
+        <p:spPr>
+          <a:xfrm>
+            <a:off x="7406637" y="2639555"/>
+            <a:ext cx="2401296" cy="1988483"/>
+          </a:xfrm>
+          <a:prstGeom prst="rect">
+            <a:avLst/>
+          </a:prstGeom>
+        </p:spPr>
+      </p:pic>
+    </p:spTree>
+    <p:extLst>
+      <p:ext uri="{BB962C8B-B14F-4D97-AF65-F5344CB8AC3E}">
+        <p14:creationId xmlns:p14="http://schemas.microsoft.com/office/powerpoint/2010/main" val="1793605326"/>
+      </p:ext>
+    </p:extLst>
+  </p:cSld>
+  <p:clrMapOvr>
+    <a:masterClrMapping/>
+  </p:clrMapOvr>
+</p:sld>
+</file>
+
+<file path=ppt/slides/slide4.xml><?xml version="1.0" encoding="utf-8"?>
+<p:sld xmlns:a="http://schemas.openxmlformats.org/drawingml/2006/main" xmlns:r="http://schemas.openxmlformats.org/officeDocument/2006/relationships" xmlns:p="http://schemas.openxmlformats.org/presentationml/2006/main">
+  <p:cSld>
+    <p:spTree>
+      <p:nvGrpSpPr>
         <p:cNvPr id="1" name=""/>
         <p:cNvGrpSpPr/>
         <p:nvPr/>
@@ -3803,10 +4209,1071 @@
           </a:p>
         </p:txBody>
       </p:sp>
+      <p:pic>
+        <p:nvPicPr>
+          <p:cNvPr id="4" name="그림 3">
+            <a:extLst>
+              <a:ext uri="{FF2B5EF4-FFF2-40B4-BE49-F238E27FC236}">
+                <a16:creationId xmlns:a16="http://schemas.microsoft.com/office/drawing/2014/main" id="{F660E23C-0E45-CF2C-83AF-15C07734F9E7}"/>
+              </a:ext>
+            </a:extLst>
+          </p:cNvPr>
+          <p:cNvPicPr>
+            <a:picLocks noChangeAspect="1"/>
+          </p:cNvPicPr>
+          <p:nvPr/>
+        </p:nvPicPr>
+        <p:blipFill>
+          <a:blip r:embed="rId2"/>
+          <a:stretch>
+            <a:fillRect/>
+          </a:stretch>
+        </p:blipFill>
+        <p:spPr>
+          <a:xfrm>
+            <a:off x="0" y="849556"/>
+            <a:ext cx="12192000" cy="5158887"/>
+          </a:xfrm>
+          <a:prstGeom prst="rect">
+            <a:avLst/>
+          </a:prstGeom>
+        </p:spPr>
+      </p:pic>
     </p:spTree>
     <p:extLst>
       <p:ext uri="{BB962C8B-B14F-4D97-AF65-F5344CB8AC3E}">
         <p14:creationId xmlns:p14="http://schemas.microsoft.com/office/powerpoint/2010/main" val="2147393750"/>
+      </p:ext>
+    </p:extLst>
+  </p:cSld>
+  <p:clrMapOvr>
+    <a:masterClrMapping/>
+  </p:clrMapOvr>
+</p:sld>
+</file>
+
+<file path=ppt/slides/slide5.xml><?xml version="1.0" encoding="utf-8"?>
+<p:sld xmlns:a="http://schemas.openxmlformats.org/drawingml/2006/main" xmlns:r="http://schemas.openxmlformats.org/officeDocument/2006/relationships" xmlns:p="http://schemas.openxmlformats.org/presentationml/2006/main">
+  <p:cSld>
+    <p:spTree>
+      <p:nvGrpSpPr>
+        <p:cNvPr id="1" name="">
+          <a:extLst>
+            <a:ext uri="{FF2B5EF4-FFF2-40B4-BE49-F238E27FC236}">
+              <a16:creationId xmlns:a16="http://schemas.microsoft.com/office/drawing/2014/main" id="{1BF2D07C-B51B-9611-80FD-685405D97EFA}"/>
+            </a:ext>
+          </a:extLst>
+        </p:cNvPr>
+        <p:cNvGrpSpPr/>
+        <p:nvPr/>
+      </p:nvGrpSpPr>
+      <p:grpSpPr>
+        <a:xfrm>
+          <a:off x="0" y="0"/>
+          <a:ext cx="0" cy="0"/>
+          <a:chOff x="0" y="0"/>
+          <a:chExt cx="0" cy="0"/>
+        </a:xfrm>
+      </p:grpSpPr>
+      <p:sp>
+        <p:nvSpPr>
+          <p:cNvPr id="6" name="제목 5">
+            <a:extLst>
+              <a:ext uri="{FF2B5EF4-FFF2-40B4-BE49-F238E27FC236}">
+                <a16:creationId xmlns:a16="http://schemas.microsoft.com/office/drawing/2014/main" id="{BCE4CCE1-ABDF-100E-7A28-BAEC2EEE0652}"/>
+              </a:ext>
+            </a:extLst>
+          </p:cNvPr>
+          <p:cNvSpPr>
+            <a:spLocks noGrp="1"/>
+          </p:cNvSpPr>
+          <p:nvPr>
+            <p:ph type="title"/>
+          </p:nvPr>
+        </p:nvSpPr>
+        <p:spPr>
+          <a:xfrm>
+            <a:off x="173182" y="171160"/>
+            <a:ext cx="2505364" cy="558511"/>
+          </a:xfrm>
+        </p:spPr>
+        <p:txBody>
+          <a:bodyPr>
+            <a:normAutofit/>
+          </a:bodyPr>
+          <a:lstStyle/>
+          <a:p>
+            <a:r>
+              <a:rPr lang="en-US" altLang="ko-KR" sz="2000" dirty="0"/>
+              <a:t>Measure Compare</a:t>
+            </a:r>
+            <a:endParaRPr lang="ko-KR" altLang="en-US" sz="2000" dirty="0"/>
+          </a:p>
+        </p:txBody>
+      </p:sp>
+      <p:sp>
+        <p:nvSpPr>
+          <p:cNvPr id="9" name="TextBox 8">
+            <a:extLst>
+              <a:ext uri="{FF2B5EF4-FFF2-40B4-BE49-F238E27FC236}">
+                <a16:creationId xmlns:a16="http://schemas.microsoft.com/office/drawing/2014/main" id="{F27755DF-4418-C354-CA29-FC623D7E7138}"/>
+              </a:ext>
+            </a:extLst>
+          </p:cNvPr>
+          <p:cNvSpPr txBox="1"/>
+          <p:nvPr/>
+        </p:nvSpPr>
+        <p:spPr>
+          <a:xfrm>
+            <a:off x="237837" y="697480"/>
+            <a:ext cx="1025236" cy="276999"/>
+          </a:xfrm>
+          <a:prstGeom prst="rect">
+            <a:avLst/>
+          </a:prstGeom>
+          <a:noFill/>
+        </p:spPr>
+        <p:txBody>
+          <a:bodyPr wrap="square" rtlCol="0">
+            <a:spAutoFit/>
+          </a:bodyPr>
+          <a:lstStyle/>
+          <a:p>
+            <a:r>
+              <a:rPr lang="ko-KR" altLang="en-US" sz="1200" dirty="0"/>
+              <a:t>노드 구조</a:t>
+            </a:r>
+          </a:p>
+        </p:txBody>
+      </p:sp>
+      <p:sp>
+        <p:nvSpPr>
+          <p:cNvPr id="10" name="TextBox 9">
+            <a:extLst>
+              <a:ext uri="{FF2B5EF4-FFF2-40B4-BE49-F238E27FC236}">
+                <a16:creationId xmlns:a16="http://schemas.microsoft.com/office/drawing/2014/main" id="{132C70CD-1C09-63B5-9422-2D492F72D44D}"/>
+              </a:ext>
+            </a:extLst>
+          </p:cNvPr>
+          <p:cNvSpPr txBox="1"/>
+          <p:nvPr/>
+        </p:nvSpPr>
+        <p:spPr>
+          <a:xfrm>
+            <a:off x="7269324" y="602763"/>
+            <a:ext cx="1025236" cy="276999"/>
+          </a:xfrm>
+          <a:prstGeom prst="rect">
+            <a:avLst/>
+          </a:prstGeom>
+          <a:noFill/>
+        </p:spPr>
+        <p:txBody>
+          <a:bodyPr wrap="square" rtlCol="0">
+            <a:spAutoFit/>
+          </a:bodyPr>
+          <a:lstStyle/>
+          <a:p>
+            <a:r>
+              <a:rPr lang="en-US" altLang="ko-KR" sz="1200" dirty="0"/>
+              <a:t>Input</a:t>
+            </a:r>
+            <a:r>
+              <a:rPr lang="ko-KR" altLang="en-US" sz="1200" dirty="0"/>
+              <a:t> </a:t>
+            </a:r>
+            <a:r>
+              <a:rPr lang="en-US" altLang="ko-KR" sz="1200" dirty="0"/>
+              <a:t>image</a:t>
+            </a:r>
+            <a:endParaRPr lang="ko-KR" altLang="en-US" sz="1200" dirty="0"/>
+          </a:p>
+        </p:txBody>
+      </p:sp>
+      <p:sp>
+        <p:nvSpPr>
+          <p:cNvPr id="11" name="TextBox 10">
+            <a:extLst>
+              <a:ext uri="{FF2B5EF4-FFF2-40B4-BE49-F238E27FC236}">
+                <a16:creationId xmlns:a16="http://schemas.microsoft.com/office/drawing/2014/main" id="{7B2E8CEE-A258-D74B-8E1E-3B7AE1509CF7}"/>
+              </a:ext>
+            </a:extLst>
+          </p:cNvPr>
+          <p:cNvSpPr txBox="1"/>
+          <p:nvPr/>
+        </p:nvSpPr>
+        <p:spPr>
+          <a:xfrm>
+            <a:off x="450274" y="3290703"/>
+            <a:ext cx="5111720" cy="646331"/>
+          </a:xfrm>
+          <a:prstGeom prst="rect">
+            <a:avLst/>
+          </a:prstGeom>
+          <a:noFill/>
+        </p:spPr>
+        <p:txBody>
+          <a:bodyPr wrap="none" rtlCol="0">
+            <a:spAutoFit/>
+          </a:bodyPr>
+          <a:lstStyle/>
+          <a:p>
+            <a:r>
+              <a:rPr lang="en-US" altLang="ko-KR" dirty="0"/>
+              <a:t>- Measure Compare</a:t>
+            </a:r>
+          </a:p>
+          <a:p>
+            <a:r>
+              <a:rPr lang="en-US" altLang="ko-KR" dirty="0" err="1"/>
+              <a:t>Inspectrion</a:t>
+            </a:r>
+            <a:r>
+              <a:rPr lang="en-US" altLang="ko-KR" dirty="0"/>
+              <a:t> Mode Shape / Noise Reduction 3</a:t>
+            </a:r>
+            <a:endParaRPr lang="ko-KR" altLang="en-US" dirty="0"/>
+          </a:p>
+        </p:txBody>
+      </p:sp>
+      <p:pic>
+        <p:nvPicPr>
+          <p:cNvPr id="5" name="그림 4">
+            <a:extLst>
+              <a:ext uri="{FF2B5EF4-FFF2-40B4-BE49-F238E27FC236}">
+                <a16:creationId xmlns:a16="http://schemas.microsoft.com/office/drawing/2014/main" id="{E1A836C0-AC04-34E5-0413-B7A32834D0D4}"/>
+              </a:ext>
+            </a:extLst>
+          </p:cNvPr>
+          <p:cNvPicPr>
+            <a:picLocks noChangeAspect="1"/>
+          </p:cNvPicPr>
+          <p:nvPr/>
+        </p:nvPicPr>
+        <p:blipFill>
+          <a:blip r:embed="rId2">
+            <a:extLst>
+              <a:ext uri="{28A0092B-C50C-407E-A947-70E740481C1C}">
+                <a14:useLocalDpi xmlns:a14="http://schemas.microsoft.com/office/drawing/2010/main" val="0"/>
+              </a:ext>
+            </a:extLst>
+          </a:blip>
+          <a:stretch>
+            <a:fillRect/>
+          </a:stretch>
+        </p:blipFill>
+        <p:spPr>
+          <a:xfrm>
+            <a:off x="7269324" y="974479"/>
+            <a:ext cx="3480041" cy="2221303"/>
+          </a:xfrm>
+          <a:prstGeom prst="rect">
+            <a:avLst/>
+          </a:prstGeom>
+        </p:spPr>
+      </p:pic>
+      <p:pic>
+        <p:nvPicPr>
+          <p:cNvPr id="12" name="그림 11">
+            <a:extLst>
+              <a:ext uri="{FF2B5EF4-FFF2-40B4-BE49-F238E27FC236}">
+                <a16:creationId xmlns:a16="http://schemas.microsoft.com/office/drawing/2014/main" id="{716A6444-8238-A7FC-25B0-7159AA768A42}"/>
+              </a:ext>
+            </a:extLst>
+          </p:cNvPr>
+          <p:cNvPicPr>
+            <a:picLocks noChangeAspect="1"/>
+          </p:cNvPicPr>
+          <p:nvPr/>
+        </p:nvPicPr>
+        <p:blipFill>
+          <a:blip r:embed="rId3"/>
+          <a:stretch>
+            <a:fillRect/>
+          </a:stretch>
+        </p:blipFill>
+        <p:spPr>
+          <a:xfrm>
+            <a:off x="7269324" y="3429000"/>
+            <a:ext cx="3507259" cy="2826237"/>
+          </a:xfrm>
+          <a:prstGeom prst="rect">
+            <a:avLst/>
+          </a:prstGeom>
+        </p:spPr>
+      </p:pic>
+      <p:pic>
+        <p:nvPicPr>
+          <p:cNvPr id="14" name="그림 13">
+            <a:extLst>
+              <a:ext uri="{FF2B5EF4-FFF2-40B4-BE49-F238E27FC236}">
+                <a16:creationId xmlns:a16="http://schemas.microsoft.com/office/drawing/2014/main" id="{AC89F56D-4F01-04BF-A548-CA91E23DA889}"/>
+              </a:ext>
+            </a:extLst>
+          </p:cNvPr>
+          <p:cNvPicPr>
+            <a:picLocks noChangeAspect="1"/>
+          </p:cNvPicPr>
+          <p:nvPr/>
+        </p:nvPicPr>
+        <p:blipFill>
+          <a:blip r:embed="rId4"/>
+          <a:srcRect l="25616" t="41267" r="28692" b="29302"/>
+          <a:stretch>
+            <a:fillRect/>
+          </a:stretch>
+        </p:blipFill>
+        <p:spPr>
+          <a:xfrm>
+            <a:off x="339436" y="1184810"/>
+            <a:ext cx="6109333" cy="1650754"/>
+          </a:xfrm>
+          <a:prstGeom prst="rect">
+            <a:avLst/>
+          </a:prstGeom>
+        </p:spPr>
+      </p:pic>
+    </p:spTree>
+    <p:extLst>
+      <p:ext uri="{BB962C8B-B14F-4D97-AF65-F5344CB8AC3E}">
+        <p14:creationId xmlns:p14="http://schemas.microsoft.com/office/powerpoint/2010/main" val="1955491267"/>
+      </p:ext>
+    </p:extLst>
+  </p:cSld>
+  <p:clrMapOvr>
+    <a:masterClrMapping/>
+  </p:clrMapOvr>
+</p:sld>
+</file>
+
+<file path=ppt/slides/slide6.xml><?xml version="1.0" encoding="utf-8"?>
+<p:sld xmlns:a="http://schemas.openxmlformats.org/drawingml/2006/main" xmlns:r="http://schemas.openxmlformats.org/officeDocument/2006/relationships" xmlns:p="http://schemas.openxmlformats.org/presentationml/2006/main">
+  <p:cSld>
+    <p:spTree>
+      <p:nvGrpSpPr>
+        <p:cNvPr id="1" name=""/>
+        <p:cNvGrpSpPr/>
+        <p:nvPr/>
+      </p:nvGrpSpPr>
+      <p:grpSpPr>
+        <a:xfrm>
+          <a:off x="0" y="0"/>
+          <a:ext cx="0" cy="0"/>
+          <a:chOff x="0" y="0"/>
+          <a:chExt cx="0" cy="0"/>
+        </a:xfrm>
+      </p:grpSpPr>
+      <p:sp>
+        <p:nvSpPr>
+          <p:cNvPr id="2" name="제목 1">
+            <a:extLst>
+              <a:ext uri="{FF2B5EF4-FFF2-40B4-BE49-F238E27FC236}">
+                <a16:creationId xmlns:a16="http://schemas.microsoft.com/office/drawing/2014/main" id="{9213654E-E4AA-A5E7-2D5E-E2F6897BAB71}"/>
+              </a:ext>
+            </a:extLst>
+          </p:cNvPr>
+          <p:cNvSpPr>
+            <a:spLocks noGrp="1"/>
+          </p:cNvSpPr>
+          <p:nvPr>
+            <p:ph type="title"/>
+          </p:nvPr>
+        </p:nvSpPr>
+        <p:spPr/>
+        <p:txBody>
+          <a:bodyPr/>
+          <a:lstStyle/>
+          <a:p>
+            <a:endParaRPr lang="ko-KR" altLang="en-US"/>
+          </a:p>
+        </p:txBody>
+      </p:sp>
+      <p:pic>
+        <p:nvPicPr>
+          <p:cNvPr id="4" name="그림 3">
+            <a:extLst>
+              <a:ext uri="{FF2B5EF4-FFF2-40B4-BE49-F238E27FC236}">
+                <a16:creationId xmlns:a16="http://schemas.microsoft.com/office/drawing/2014/main" id="{AB1965D9-01F7-B6B4-8F8A-08F15879B83B}"/>
+              </a:ext>
+            </a:extLst>
+          </p:cNvPr>
+          <p:cNvPicPr>
+            <a:picLocks noChangeAspect="1"/>
+          </p:cNvPicPr>
+          <p:nvPr/>
+        </p:nvPicPr>
+        <p:blipFill>
+          <a:blip r:embed="rId2"/>
+          <a:stretch>
+            <a:fillRect/>
+          </a:stretch>
+        </p:blipFill>
+        <p:spPr>
+          <a:xfrm>
+            <a:off x="0" y="871793"/>
+            <a:ext cx="12192000" cy="5114414"/>
+          </a:xfrm>
+          <a:prstGeom prst="rect">
+            <a:avLst/>
+          </a:prstGeom>
+        </p:spPr>
+      </p:pic>
+    </p:spTree>
+    <p:extLst>
+      <p:ext uri="{BB962C8B-B14F-4D97-AF65-F5344CB8AC3E}">
+        <p14:creationId xmlns:p14="http://schemas.microsoft.com/office/powerpoint/2010/main" val="1667325372"/>
+      </p:ext>
+    </p:extLst>
+  </p:cSld>
+  <p:clrMapOvr>
+    <a:masterClrMapping/>
+  </p:clrMapOvr>
+</p:sld>
+</file>
+
+<file path=ppt/slides/slide7.xml><?xml version="1.0" encoding="utf-8"?>
+<p:sld xmlns:a="http://schemas.openxmlformats.org/drawingml/2006/main" xmlns:r="http://schemas.openxmlformats.org/officeDocument/2006/relationships" xmlns:p="http://schemas.openxmlformats.org/presentationml/2006/main">
+  <p:cSld>
+    <p:spTree>
+      <p:nvGrpSpPr>
+        <p:cNvPr id="1" name="">
+          <a:extLst>
+            <a:ext uri="{FF2B5EF4-FFF2-40B4-BE49-F238E27FC236}">
+              <a16:creationId xmlns:a16="http://schemas.microsoft.com/office/drawing/2014/main" id="{0A8F081B-68BA-9C1A-1B35-CF20CA68920F}"/>
+            </a:ext>
+          </a:extLst>
+        </p:cNvPr>
+        <p:cNvGrpSpPr/>
+        <p:nvPr/>
+      </p:nvGrpSpPr>
+      <p:grpSpPr>
+        <a:xfrm>
+          <a:off x="0" y="0"/>
+          <a:ext cx="0" cy="0"/>
+          <a:chOff x="0" y="0"/>
+          <a:chExt cx="0" cy="0"/>
+        </a:xfrm>
+      </p:grpSpPr>
+      <p:sp>
+        <p:nvSpPr>
+          <p:cNvPr id="6" name="제목 5">
+            <a:extLst>
+              <a:ext uri="{FF2B5EF4-FFF2-40B4-BE49-F238E27FC236}">
+                <a16:creationId xmlns:a16="http://schemas.microsoft.com/office/drawing/2014/main" id="{63F8317C-CAFF-3CF9-2FB9-74F70BBFCDA6}"/>
+              </a:ext>
+            </a:extLst>
+          </p:cNvPr>
+          <p:cNvSpPr>
+            <a:spLocks noGrp="1"/>
+          </p:cNvSpPr>
+          <p:nvPr>
+            <p:ph type="title"/>
+          </p:nvPr>
+        </p:nvSpPr>
+        <p:spPr>
+          <a:xfrm>
+            <a:off x="173182" y="171160"/>
+            <a:ext cx="2505364" cy="558511"/>
+          </a:xfrm>
+        </p:spPr>
+        <p:txBody>
+          <a:bodyPr>
+            <a:normAutofit/>
+          </a:bodyPr>
+          <a:lstStyle/>
+          <a:p>
+            <a:r>
+              <a:rPr lang="en-US" altLang="ko-KR" sz="2000" dirty="0"/>
+              <a:t>Measure Level</a:t>
+            </a:r>
+            <a:endParaRPr lang="ko-KR" altLang="en-US" sz="2000" dirty="0"/>
+          </a:p>
+        </p:txBody>
+      </p:sp>
+      <p:sp>
+        <p:nvSpPr>
+          <p:cNvPr id="9" name="TextBox 8">
+            <a:extLst>
+              <a:ext uri="{FF2B5EF4-FFF2-40B4-BE49-F238E27FC236}">
+                <a16:creationId xmlns:a16="http://schemas.microsoft.com/office/drawing/2014/main" id="{F9A241F5-2FCD-A38C-A112-39F731A767B8}"/>
+              </a:ext>
+            </a:extLst>
+          </p:cNvPr>
+          <p:cNvSpPr txBox="1"/>
+          <p:nvPr/>
+        </p:nvSpPr>
+        <p:spPr>
+          <a:xfrm>
+            <a:off x="237837" y="697480"/>
+            <a:ext cx="1025236" cy="276999"/>
+          </a:xfrm>
+          <a:prstGeom prst="rect">
+            <a:avLst/>
+          </a:prstGeom>
+          <a:noFill/>
+        </p:spPr>
+        <p:txBody>
+          <a:bodyPr wrap="square" rtlCol="0">
+            <a:spAutoFit/>
+          </a:bodyPr>
+          <a:lstStyle/>
+          <a:p>
+            <a:r>
+              <a:rPr lang="ko-KR" altLang="en-US" sz="1200" dirty="0"/>
+              <a:t>노드 구조</a:t>
+            </a:r>
+          </a:p>
+        </p:txBody>
+      </p:sp>
+      <p:sp>
+        <p:nvSpPr>
+          <p:cNvPr id="10" name="TextBox 9">
+            <a:extLst>
+              <a:ext uri="{FF2B5EF4-FFF2-40B4-BE49-F238E27FC236}">
+                <a16:creationId xmlns:a16="http://schemas.microsoft.com/office/drawing/2014/main" id="{080143BF-A944-F739-81AD-B2499D5A6078}"/>
+              </a:ext>
+            </a:extLst>
+          </p:cNvPr>
+          <p:cNvSpPr txBox="1"/>
+          <p:nvPr/>
+        </p:nvSpPr>
+        <p:spPr>
+          <a:xfrm>
+            <a:off x="7269324" y="602763"/>
+            <a:ext cx="1025236" cy="276999"/>
+          </a:xfrm>
+          <a:prstGeom prst="rect">
+            <a:avLst/>
+          </a:prstGeom>
+          <a:noFill/>
+        </p:spPr>
+        <p:txBody>
+          <a:bodyPr wrap="square" rtlCol="0">
+            <a:spAutoFit/>
+          </a:bodyPr>
+          <a:lstStyle/>
+          <a:p>
+            <a:r>
+              <a:rPr lang="en-US" altLang="ko-KR" sz="1200" dirty="0"/>
+              <a:t>Input</a:t>
+            </a:r>
+            <a:r>
+              <a:rPr lang="ko-KR" altLang="en-US" sz="1200" dirty="0"/>
+              <a:t> </a:t>
+            </a:r>
+            <a:r>
+              <a:rPr lang="en-US" altLang="ko-KR" sz="1200" dirty="0"/>
+              <a:t>image</a:t>
+            </a:r>
+            <a:endParaRPr lang="ko-KR" altLang="en-US" sz="1200" dirty="0"/>
+          </a:p>
+        </p:txBody>
+      </p:sp>
+      <p:sp>
+        <p:nvSpPr>
+          <p:cNvPr id="11" name="TextBox 10">
+            <a:extLst>
+              <a:ext uri="{FF2B5EF4-FFF2-40B4-BE49-F238E27FC236}">
+                <a16:creationId xmlns:a16="http://schemas.microsoft.com/office/drawing/2014/main" id="{95D0FAAC-23AC-AE75-96B7-E0AA46B9D552}"/>
+              </a:ext>
+            </a:extLst>
+          </p:cNvPr>
+          <p:cNvSpPr txBox="1"/>
+          <p:nvPr/>
+        </p:nvSpPr>
+        <p:spPr>
+          <a:xfrm>
+            <a:off x="85757" y="4924475"/>
+            <a:ext cx="7114063" cy="646331"/>
+          </a:xfrm>
+          <a:prstGeom prst="rect">
+            <a:avLst/>
+          </a:prstGeom>
+          <a:noFill/>
+        </p:spPr>
+        <p:txBody>
+          <a:bodyPr wrap="none" rtlCol="0">
+            <a:spAutoFit/>
+          </a:bodyPr>
+          <a:lstStyle/>
+          <a:p>
+            <a:r>
+              <a:rPr lang="en-US" altLang="ko-KR" dirty="0"/>
+              <a:t>- Measure Level</a:t>
+            </a:r>
+          </a:p>
+          <a:p>
+            <a:r>
+              <a:rPr lang="en-US" altLang="ko-KR" dirty="0"/>
+              <a:t>Search Offset Y 90 / Search Height 100 / Decision Value 105.0000</a:t>
+            </a:r>
+            <a:endParaRPr lang="ko-KR" altLang="en-US" dirty="0"/>
+          </a:p>
+        </p:txBody>
+      </p:sp>
+      <p:pic>
+        <p:nvPicPr>
+          <p:cNvPr id="3" name="그림 2">
+            <a:extLst>
+              <a:ext uri="{FF2B5EF4-FFF2-40B4-BE49-F238E27FC236}">
+                <a16:creationId xmlns:a16="http://schemas.microsoft.com/office/drawing/2014/main" id="{A7EAD024-8E37-7C15-B9D7-B76C9F1D6738}"/>
+              </a:ext>
+            </a:extLst>
+          </p:cNvPr>
+          <p:cNvPicPr>
+            <a:picLocks noChangeAspect="1"/>
+          </p:cNvPicPr>
+          <p:nvPr/>
+        </p:nvPicPr>
+        <p:blipFill>
+          <a:blip r:embed="rId2"/>
+          <a:stretch>
+            <a:fillRect/>
+          </a:stretch>
+        </p:blipFill>
+        <p:spPr>
+          <a:xfrm>
+            <a:off x="7348282" y="3429000"/>
+            <a:ext cx="3232279" cy="2689634"/>
+          </a:xfrm>
+          <a:prstGeom prst="rect">
+            <a:avLst/>
+          </a:prstGeom>
+        </p:spPr>
+      </p:pic>
+      <p:pic>
+        <p:nvPicPr>
+          <p:cNvPr id="7" name="그림 6">
+            <a:extLst>
+              <a:ext uri="{FF2B5EF4-FFF2-40B4-BE49-F238E27FC236}">
+                <a16:creationId xmlns:a16="http://schemas.microsoft.com/office/drawing/2014/main" id="{A59E4FBC-17C5-E198-D4A9-EBAA60B6CFA2}"/>
+              </a:ext>
+            </a:extLst>
+          </p:cNvPr>
+          <p:cNvPicPr>
+            <a:picLocks noChangeAspect="1"/>
+          </p:cNvPicPr>
+          <p:nvPr/>
+        </p:nvPicPr>
+        <p:blipFill>
+          <a:blip r:embed="rId3">
+            <a:extLst>
+              <a:ext uri="{28A0092B-C50C-407E-A947-70E740481C1C}">
+                <a14:useLocalDpi xmlns:a14="http://schemas.microsoft.com/office/drawing/2010/main" val="0"/>
+              </a:ext>
+            </a:extLst>
+          </a:blip>
+          <a:stretch>
+            <a:fillRect/>
+          </a:stretch>
+        </p:blipFill>
+        <p:spPr>
+          <a:xfrm>
+            <a:off x="7334122" y="879762"/>
+            <a:ext cx="3206470" cy="2410941"/>
+          </a:xfrm>
+          <a:prstGeom prst="rect">
+            <a:avLst/>
+          </a:prstGeom>
+        </p:spPr>
+      </p:pic>
+      <p:pic>
+        <p:nvPicPr>
+          <p:cNvPr id="8" name="그림 7">
+            <a:extLst>
+              <a:ext uri="{FF2B5EF4-FFF2-40B4-BE49-F238E27FC236}">
+                <a16:creationId xmlns:a16="http://schemas.microsoft.com/office/drawing/2014/main" id="{2BA1EAC6-1BAD-C0D5-757E-9DB85A7FB84F}"/>
+              </a:ext>
+            </a:extLst>
+          </p:cNvPr>
+          <p:cNvPicPr>
+            <a:picLocks noChangeAspect="1"/>
+          </p:cNvPicPr>
+          <p:nvPr/>
+        </p:nvPicPr>
+        <p:blipFill>
+          <a:blip r:embed="rId4"/>
+          <a:srcRect l="31836" t="33049" r="30016" b="28108"/>
+          <a:stretch>
+            <a:fillRect/>
+          </a:stretch>
+        </p:blipFill>
+        <p:spPr>
+          <a:xfrm>
+            <a:off x="353032" y="1255991"/>
+            <a:ext cx="6245086" cy="2689634"/>
+          </a:xfrm>
+          <a:prstGeom prst="rect">
+            <a:avLst/>
+          </a:prstGeom>
+        </p:spPr>
+      </p:pic>
+    </p:spTree>
+    <p:extLst>
+      <p:ext uri="{BB962C8B-B14F-4D97-AF65-F5344CB8AC3E}">
+        <p14:creationId xmlns:p14="http://schemas.microsoft.com/office/powerpoint/2010/main" val="3356352889"/>
+      </p:ext>
+    </p:extLst>
+  </p:cSld>
+  <p:clrMapOvr>
+    <a:masterClrMapping/>
+  </p:clrMapOvr>
+</p:sld>
+</file>
+
+<file path=ppt/slides/slide8.xml><?xml version="1.0" encoding="utf-8"?>
+<p:sld xmlns:a="http://schemas.openxmlformats.org/drawingml/2006/main" xmlns:r="http://schemas.openxmlformats.org/officeDocument/2006/relationships" xmlns:p="http://schemas.openxmlformats.org/presentationml/2006/main">
+  <p:cSld>
+    <p:spTree>
+      <p:nvGrpSpPr>
+        <p:cNvPr id="1" name=""/>
+        <p:cNvGrpSpPr/>
+        <p:nvPr/>
+      </p:nvGrpSpPr>
+      <p:grpSpPr>
+        <a:xfrm>
+          <a:off x="0" y="0"/>
+          <a:ext cx="0" cy="0"/>
+          <a:chOff x="0" y="0"/>
+          <a:chExt cx="0" cy="0"/>
+        </a:xfrm>
+      </p:grpSpPr>
+      <p:sp>
+        <p:nvSpPr>
+          <p:cNvPr id="2" name="제목 1">
+            <a:extLst>
+              <a:ext uri="{FF2B5EF4-FFF2-40B4-BE49-F238E27FC236}">
+                <a16:creationId xmlns:a16="http://schemas.microsoft.com/office/drawing/2014/main" id="{977296A0-FA13-79DE-C737-3B4753B17A62}"/>
+              </a:ext>
+            </a:extLst>
+          </p:cNvPr>
+          <p:cNvSpPr>
+            <a:spLocks noGrp="1"/>
+          </p:cNvSpPr>
+          <p:nvPr>
+            <p:ph type="title"/>
+          </p:nvPr>
+        </p:nvSpPr>
+        <p:spPr/>
+        <p:txBody>
+          <a:bodyPr/>
+          <a:lstStyle/>
+          <a:p>
+            <a:endParaRPr lang="ko-KR" altLang="en-US"/>
+          </a:p>
+        </p:txBody>
+      </p:sp>
+      <p:pic>
+        <p:nvPicPr>
+          <p:cNvPr id="4" name="그림 3">
+            <a:extLst>
+              <a:ext uri="{FF2B5EF4-FFF2-40B4-BE49-F238E27FC236}">
+                <a16:creationId xmlns:a16="http://schemas.microsoft.com/office/drawing/2014/main" id="{25060C03-97CD-BECD-4D45-2C1E90E12E4B}"/>
+              </a:ext>
+            </a:extLst>
+          </p:cNvPr>
+          <p:cNvPicPr>
+            <a:picLocks noChangeAspect="1"/>
+          </p:cNvPicPr>
+          <p:nvPr/>
+        </p:nvPicPr>
+        <p:blipFill>
+          <a:blip r:embed="rId2"/>
+          <a:stretch>
+            <a:fillRect/>
+          </a:stretch>
+        </p:blipFill>
+        <p:spPr>
+          <a:xfrm>
+            <a:off x="0" y="850535"/>
+            <a:ext cx="12192000" cy="5156930"/>
+          </a:xfrm>
+          <a:prstGeom prst="rect">
+            <a:avLst/>
+          </a:prstGeom>
+        </p:spPr>
+      </p:pic>
+    </p:spTree>
+    <p:extLst>
+      <p:ext uri="{BB962C8B-B14F-4D97-AF65-F5344CB8AC3E}">
+        <p14:creationId xmlns:p14="http://schemas.microsoft.com/office/powerpoint/2010/main" val="532919494"/>
+      </p:ext>
+    </p:extLst>
+  </p:cSld>
+  <p:clrMapOvr>
+    <a:masterClrMapping/>
+  </p:clrMapOvr>
+</p:sld>
+</file>
+
+<file path=ppt/slides/slide9.xml><?xml version="1.0" encoding="utf-8"?>
+<p:sld xmlns:a="http://schemas.openxmlformats.org/drawingml/2006/main" xmlns:r="http://schemas.openxmlformats.org/officeDocument/2006/relationships" xmlns:p="http://schemas.openxmlformats.org/presentationml/2006/main">
+  <p:cSld>
+    <p:spTree>
+      <p:nvGrpSpPr>
+        <p:cNvPr id="1" name="">
+          <a:extLst>
+            <a:ext uri="{FF2B5EF4-FFF2-40B4-BE49-F238E27FC236}">
+              <a16:creationId xmlns:a16="http://schemas.microsoft.com/office/drawing/2014/main" id="{4F99117C-C6FC-55A0-D53F-2BC1DFFB3BCC}"/>
+            </a:ext>
+          </a:extLst>
+        </p:cNvPr>
+        <p:cNvGrpSpPr/>
+        <p:nvPr/>
+      </p:nvGrpSpPr>
+      <p:grpSpPr>
+        <a:xfrm>
+          <a:off x="0" y="0"/>
+          <a:ext cx="0" cy="0"/>
+          <a:chOff x="0" y="0"/>
+          <a:chExt cx="0" cy="0"/>
+        </a:xfrm>
+      </p:grpSpPr>
+      <p:sp>
+        <p:nvSpPr>
+          <p:cNvPr id="6" name="제목 5">
+            <a:extLst>
+              <a:ext uri="{FF2B5EF4-FFF2-40B4-BE49-F238E27FC236}">
+                <a16:creationId xmlns:a16="http://schemas.microsoft.com/office/drawing/2014/main" id="{542B510F-A4D7-3D26-EC83-F7D813935F8B}"/>
+              </a:ext>
+            </a:extLst>
+          </p:cNvPr>
+          <p:cNvSpPr>
+            <a:spLocks noGrp="1"/>
+          </p:cNvSpPr>
+          <p:nvPr>
+            <p:ph type="title"/>
+          </p:nvPr>
+        </p:nvSpPr>
+        <p:spPr>
+          <a:xfrm>
+            <a:off x="173182" y="171160"/>
+            <a:ext cx="2505364" cy="558511"/>
+          </a:xfrm>
+        </p:spPr>
+        <p:txBody>
+          <a:bodyPr>
+            <a:normAutofit/>
+          </a:bodyPr>
+          <a:lstStyle/>
+          <a:p>
+            <a:r>
+              <a:rPr lang="en-US" altLang="ko-KR" sz="2000" dirty="0"/>
+              <a:t>Measure Distance</a:t>
+            </a:r>
+            <a:endParaRPr lang="ko-KR" altLang="en-US" sz="2000" dirty="0"/>
+          </a:p>
+        </p:txBody>
+      </p:sp>
+      <p:sp>
+        <p:nvSpPr>
+          <p:cNvPr id="9" name="TextBox 8">
+            <a:extLst>
+              <a:ext uri="{FF2B5EF4-FFF2-40B4-BE49-F238E27FC236}">
+                <a16:creationId xmlns:a16="http://schemas.microsoft.com/office/drawing/2014/main" id="{00882B22-55F2-B5F5-D6A2-9195AB9D79BF}"/>
+              </a:ext>
+            </a:extLst>
+          </p:cNvPr>
+          <p:cNvSpPr txBox="1"/>
+          <p:nvPr/>
+        </p:nvSpPr>
+        <p:spPr>
+          <a:xfrm>
+            <a:off x="237837" y="697480"/>
+            <a:ext cx="1025236" cy="276999"/>
+          </a:xfrm>
+          <a:prstGeom prst="rect">
+            <a:avLst/>
+          </a:prstGeom>
+          <a:noFill/>
+        </p:spPr>
+        <p:txBody>
+          <a:bodyPr wrap="square" rtlCol="0">
+            <a:spAutoFit/>
+          </a:bodyPr>
+          <a:lstStyle/>
+          <a:p>
+            <a:r>
+              <a:rPr lang="ko-KR" altLang="en-US" sz="1200" dirty="0"/>
+              <a:t>노드 구조</a:t>
+            </a:r>
+          </a:p>
+        </p:txBody>
+      </p:sp>
+      <p:sp>
+        <p:nvSpPr>
+          <p:cNvPr id="10" name="TextBox 9">
+            <a:extLst>
+              <a:ext uri="{FF2B5EF4-FFF2-40B4-BE49-F238E27FC236}">
+                <a16:creationId xmlns:a16="http://schemas.microsoft.com/office/drawing/2014/main" id="{0D51E96E-D5C6-2F30-D909-D57168CF9FB1}"/>
+              </a:ext>
+            </a:extLst>
+          </p:cNvPr>
+          <p:cNvSpPr txBox="1"/>
+          <p:nvPr/>
+        </p:nvSpPr>
+        <p:spPr>
+          <a:xfrm>
+            <a:off x="7269324" y="602763"/>
+            <a:ext cx="1025236" cy="276999"/>
+          </a:xfrm>
+          <a:prstGeom prst="rect">
+            <a:avLst/>
+          </a:prstGeom>
+          <a:noFill/>
+        </p:spPr>
+        <p:txBody>
+          <a:bodyPr wrap="square" rtlCol="0">
+            <a:spAutoFit/>
+          </a:bodyPr>
+          <a:lstStyle/>
+          <a:p>
+            <a:r>
+              <a:rPr lang="en-US" altLang="ko-KR" sz="1200" dirty="0"/>
+              <a:t>Input</a:t>
+            </a:r>
+            <a:r>
+              <a:rPr lang="ko-KR" altLang="en-US" sz="1200" dirty="0"/>
+              <a:t> </a:t>
+            </a:r>
+            <a:r>
+              <a:rPr lang="en-US" altLang="ko-KR" sz="1200" dirty="0"/>
+              <a:t>image</a:t>
+            </a:r>
+            <a:endParaRPr lang="ko-KR" altLang="en-US" sz="1200" dirty="0"/>
+          </a:p>
+        </p:txBody>
+      </p:sp>
+      <p:pic>
+        <p:nvPicPr>
+          <p:cNvPr id="4" name="그림 3">
+            <a:extLst>
+              <a:ext uri="{FF2B5EF4-FFF2-40B4-BE49-F238E27FC236}">
+                <a16:creationId xmlns:a16="http://schemas.microsoft.com/office/drawing/2014/main" id="{62697203-6801-2644-7021-27D0083ECC13}"/>
+              </a:ext>
+            </a:extLst>
+          </p:cNvPr>
+          <p:cNvPicPr>
+            <a:picLocks noChangeAspect="1"/>
+          </p:cNvPicPr>
+          <p:nvPr/>
+        </p:nvPicPr>
+        <p:blipFill>
+          <a:blip r:embed="rId2"/>
+          <a:stretch>
+            <a:fillRect/>
+          </a:stretch>
+        </p:blipFill>
+        <p:spPr>
+          <a:xfrm>
+            <a:off x="237837" y="1170704"/>
+            <a:ext cx="6630325" cy="1829055"/>
+          </a:xfrm>
+          <a:prstGeom prst="rect">
+            <a:avLst/>
+          </a:prstGeom>
+        </p:spPr>
+      </p:pic>
+      <p:pic>
+        <p:nvPicPr>
+          <p:cNvPr id="12" name="그림 11">
+            <a:extLst>
+              <a:ext uri="{FF2B5EF4-FFF2-40B4-BE49-F238E27FC236}">
+                <a16:creationId xmlns:a16="http://schemas.microsoft.com/office/drawing/2014/main" id="{FAB306AA-7CB6-BE12-61C8-465F9700B4AE}"/>
+              </a:ext>
+            </a:extLst>
+          </p:cNvPr>
+          <p:cNvPicPr>
+            <a:picLocks noChangeAspect="1"/>
+          </p:cNvPicPr>
+          <p:nvPr/>
+        </p:nvPicPr>
+        <p:blipFill>
+          <a:blip r:embed="rId3">
+            <a:extLst>
+              <a:ext uri="{28A0092B-C50C-407E-A947-70E740481C1C}">
+                <a14:useLocalDpi xmlns:a14="http://schemas.microsoft.com/office/drawing/2010/main" val="0"/>
+              </a:ext>
+            </a:extLst>
+          </a:blip>
+          <a:stretch>
+            <a:fillRect/>
+          </a:stretch>
+        </p:blipFill>
+        <p:spPr>
+          <a:xfrm>
+            <a:off x="7269324" y="1035217"/>
+            <a:ext cx="4606999" cy="2100028"/>
+          </a:xfrm>
+          <a:prstGeom prst="rect">
+            <a:avLst/>
+          </a:prstGeom>
+          <a:solidFill>
+            <a:srgbClr val="FFFFFF">
+              <a:shade val="85000"/>
+            </a:srgbClr>
+          </a:solidFill>
+          <a:ln w="88900" cap="sq">
+            <a:solidFill>
+              <a:srgbClr val="FFFFFF"/>
+            </a:solidFill>
+            <a:miter lim="800000"/>
+          </a:ln>
+          <a:effectLst>
+            <a:outerShdw blurRad="55000" dist="18000" dir="5400000" algn="tl" rotWithShape="0">
+              <a:srgbClr val="000000">
+                <a:alpha val="40000"/>
+              </a:srgbClr>
+            </a:outerShdw>
+          </a:effectLst>
+          <a:scene3d>
+            <a:camera prst="orthographicFront"/>
+            <a:lightRig rig="twoPt" dir="t">
+              <a:rot lat="0" lon="0" rev="7200000"/>
+            </a:lightRig>
+          </a:scene3d>
+          <a:sp3d>
+            <a:bevelT w="25400" h="19050"/>
+            <a:contourClr>
+              <a:srgbClr val="FFFFFF"/>
+            </a:contourClr>
+          </a:sp3d>
+        </p:spPr>
+      </p:pic>
+      <p:pic>
+        <p:nvPicPr>
+          <p:cNvPr id="14" name="그림 13">
+            <a:extLst>
+              <a:ext uri="{FF2B5EF4-FFF2-40B4-BE49-F238E27FC236}">
+                <a16:creationId xmlns:a16="http://schemas.microsoft.com/office/drawing/2014/main" id="{5AFD5161-8012-9DDB-C9CC-15EEEB13C2BA}"/>
+              </a:ext>
+            </a:extLst>
+          </p:cNvPr>
+          <p:cNvPicPr>
+            <a:picLocks noChangeAspect="1"/>
+          </p:cNvPicPr>
+          <p:nvPr/>
+        </p:nvPicPr>
+        <p:blipFill>
+          <a:blip r:embed="rId4"/>
+          <a:stretch>
+            <a:fillRect/>
+          </a:stretch>
+        </p:blipFill>
+        <p:spPr>
+          <a:xfrm>
+            <a:off x="7591346" y="3429000"/>
+            <a:ext cx="3962953" cy="3210373"/>
+          </a:xfrm>
+          <a:prstGeom prst="rect">
+            <a:avLst/>
+          </a:prstGeom>
+        </p:spPr>
+      </p:pic>
+    </p:spTree>
+    <p:extLst>
+      <p:ext uri="{BB962C8B-B14F-4D97-AF65-F5344CB8AC3E}">
+        <p14:creationId xmlns:p14="http://schemas.microsoft.com/office/powerpoint/2010/main" val="2570242123"/>
       </p:ext>
     </p:extLst>
   </p:cSld>

</xml_diff>